<commit_message>
e2e z.ai improve pptx
</commit_message>
<xml_diff>
--- a/PowerPoint_Agent_Tools_Presentation.pptx
+++ b/PowerPoint_Agent_Tools_Presentation.pptx
@@ -4498,7 +4498,47 @@
           <a:lstStyle/>
           <a:p>
             <a:r>
-              <a:t>5 Flexible Positioning Systems</a:t>
+              <a:rPr lang="en-US" sz="2800" b="1" dirty="0">
+                <a:solidFill>
+                  <a:srgbClr val="1F497D"/>
+                </a:solidFill>
+                <a:latin typeface="Calibri"/>
+              </a:rPr>
+              <a:t>Flexible Positioning Systems</a:t>
+            </a:r>
+          </a:p>
+        </p:txBody>
+      </p:sp>
+      <p:sp>
+        <p:nvSpPr>
+          <p:cNvPr id="7" name="Subtitle"/>
+          <p:cNvSpPr txBox="1"/>
+          <p:nvPr/>
+        </p:nvSpPr>
+        <p:spPr>
+          <a:xfrm>
+            <a:off x="457200" y="1371600"/>
+            <a:ext cx="8229600" cy="457200"/>
+          </a:xfrm>
+          <a:prstGeom prst="rect">
+            <a:avLst/>
+          </a:prstGeom>
+          <a:noFill/>
+        </p:spPr>
+        <p:txBody>
+          <a:bodyPr wrap="square">
+            <a:spAutoFit/>
+          </a:bodyPr>
+          <a:lstStyle/>
+          <a:p>
+            <a:r>
+              <a:rPr lang="en-US" sz="1400" dirty="0">
+                <a:solidFill>
+                  <a:srgbClr val="595959"/>
+                </a:solidFill>
+                <a:latin typeface="Calibri"/>
+              </a:rPr>
+              <a:t>Five complementary systems for placing elements precisely on any slide layout</a:t>
             </a:r>
           </a:p>
         </p:txBody>
@@ -4529,8 +4569,8 @@
           <p:nvPr/>
         </p:nvGraphicFramePr>
         <p:xfrm>
-          <a:off x="609584" y="1714500"/>
-          <a:ext cx="10972525" cy="4457700"/>
+          <a:off x="457200" y="1920240"/>
+          <a:ext cx="11277600" cy="4114800"/>
         </p:xfrm>
         <a:graphic>
           <a:graphicData uri="http://schemas.openxmlformats.org/drawingml/2006/table">
@@ -4539,236 +4579,434 @@
                 <a:tableStyleId>{5C22544A-7EE6-4342-B048-85BDC9FD1C3A}</a:tableStyleId>
               </a:tblPr>
               <a:tblGrid>
-                <a:gridCol w="3657508"/>
-                <a:gridCol w="3657508"/>
-                <a:gridCol w="3657509"/>
+                <a:gridCol w="2194560"/>
+                <a:gridCol w="3200400"/>
+                <a:gridCol w="5882640"/>
               </a:tblGrid>
-              <a:tr h="742950">
+              <a:tr h="685800">
                 <a:tc>
                   <a:txBody>
                     <a:bodyPr/>
                     <a:lstStyle/>
                     <a:p>
+                      <a:pPr algn="ctr"/>
                       <a:r>
+                        <a:rPr lang="en-US" sz="1400" b="1" dirty="0">
+                          <a:solidFill>
+                            <a:srgbClr val="FFFFFF"/>
+                          </a:solidFill>
+                          <a:latin typeface="Calibri"/>
+                        </a:rPr>
                         <a:t>System</a:t>
                       </a:r>
                     </a:p>
                   </a:txBody>
-                  <a:tcPr/>
+                  <a:tcPr>
+                    <a:solidFill>
+                      <a:srgbClr val="1F497D"/>
+                    </a:solidFill>
+                  </a:tcPr>
                 </a:tc>
                 <a:tc>
                   <a:txBody>
                     <a:bodyPr/>
                     <a:lstStyle/>
                     <a:p>
+                      <a:pPr algn="ctr"/>
                       <a:r>
-                        <a:t>Format</a:t>
+                        <a:rPr lang="en-US" sz="1400" b="1" dirty="0">
+                          <a:solidFill>
+                            <a:srgbClr val="FFFFFF"/>
+                          </a:solidFill>
+                          <a:latin typeface="Calibri"/>
+                        </a:rPr>
+                        <a:t>Format Example</a:t>
                       </a:r>
                     </a:p>
                   </a:txBody>
-                  <a:tcPr/>
+                  <a:tcPr>
+                    <a:solidFill>
+                      <a:srgbClr val="1F497D"/>
+                    </a:solidFill>
+                  </a:tcPr>
                 </a:tc>
                 <a:tc>
                   <a:txBody>
                     <a:bodyPr/>
                     <a:lstStyle/>
                     <a:p>
+                      <a:pPr algn="ctr"/>
                       <a:r>
+                        <a:rPr lang="en-US" sz="1400" b="1" dirty="0">
+                          <a:solidFill>
+                            <a:srgbClr val="FFFFFF"/>
+                          </a:solidFill>
+                          <a:latin typeface="Calibri"/>
+                        </a:rPr>
                         <a:t>Best For</a:t>
                       </a:r>
                     </a:p>
                   </a:txBody>
-                  <a:tcPr/>
+                  <a:tcPr>
+                    <a:solidFill>
+                      <a:srgbClr val="1F497D"/>
+                    </a:solidFill>
+                  </a:tcPr>
                 </a:tc>
               </a:tr>
-              <a:tr h="742950">
+              <a:tr h="685800">
                 <a:tc>
                   <a:txBody>
                     <a:bodyPr/>
                     <a:lstStyle/>
                     <a:p>
+                      <a:pPr algn="l"/>
                       <a:r>
+                        <a:rPr lang="en-US" sz="1100" b="1" dirty="0">
+                          <a:solidFill>
+                            <a:srgbClr val="1F497D"/>
+                          </a:solidFill>
+                          <a:latin typeface="Calibri"/>
+                        </a:rPr>
                         <a:t>Percentage</a:t>
                       </a:r>
                     </a:p>
                   </a:txBody>
-                  <a:tcPr/>
+                  <a:tcPr>
+                    <a:solidFill>
+                      <a:srgbClr val="DCE6F1"/>
+                    </a:solidFill>
+                  </a:tcPr>
                 </a:tc>
                 <a:tc>
                   <a:txBody>
                     <a:bodyPr/>
                     <a:lstStyle/>
                     <a:p>
+                      <a:pPr algn="l"/>
                       <a:r>
+                        <a:rPr lang="en-US" sz="1100" dirty="0">
+                          <a:solidFill>
+                            <a:srgbClr val="333333"/>
+                          </a:solidFill>
+                          <a:latin typeface="Courier New"/>
+                        </a:rPr>
                         <a:t>{left:10%, top:20%}</a:t>
                       </a:r>
                     </a:p>
                   </a:txBody>
-                  <a:tcPr/>
+                  <a:tcPr>
+                    <a:solidFill>
+                      <a:srgbClr val="DCE6F1"/>
+                    </a:solidFill>
+                  </a:tcPr>
                 </a:tc>
                 <a:tc>
                   <a:txBody>
                     <a:bodyPr/>
                     <a:lstStyle/>
                     <a:p>
+                      <a:pPr algn="l"/>
                       <a:r>
-                        <a:t>Responsive Layouts</a:t>
+                        <a:rPr lang="en-US" sz="1100" dirty="0">
+                          <a:solidFill>
+                            <a:srgbClr val="333333"/>
+                          </a:solidFill>
+                          <a:latin typeface="Calibri"/>
+                        </a:rPr>
+                        <a:t>Responsive layouts that adapt to any slide size</a:t>
                       </a:r>
                     </a:p>
                   </a:txBody>
-                  <a:tcPr/>
+                  <a:tcPr>
+                    <a:solidFill>
+                      <a:srgbClr val="DCE6F1"/>
+                    </a:solidFill>
+                  </a:tcPr>
                 </a:tc>
               </a:tr>
-              <a:tr h="742950">
+              <a:tr h="685800">
                 <a:tc>
                   <a:txBody>
                     <a:bodyPr/>
                     <a:lstStyle/>
                     <a:p>
+                      <a:pPr algn="l"/>
                       <a:r>
+                        <a:rPr lang="en-US" sz="1100" b="1" dirty="0">
+                          <a:solidFill>
+                            <a:srgbClr val="1F497D"/>
+                          </a:solidFill>
+                          <a:latin typeface="Calibri"/>
+                        </a:rPr>
                         <a:t>Anchor</a:t>
                       </a:r>
                     </a:p>
                   </a:txBody>
-                  <a:tcPr/>
+                  <a:tcPr>
+                    <a:solidFill>
+                      <a:srgbClr val="FFFFFF"/>
+                    </a:solidFill>
+                  </a:tcPr>
                 </a:tc>
                 <a:tc>
                   <a:txBody>
                     <a:bodyPr/>
                     <a:lstStyle/>
                     <a:p>
+                      <a:pPr algn="l"/>
                       <a:r>
+                        <a:rPr lang="en-US" sz="1100" dirty="0">
+                          <a:solidFill>
+                            <a:srgbClr val="333333"/>
+                          </a:solidFill>
+                          <a:latin typeface="Courier New"/>
+                        </a:rPr>
                         <a:t>{anchor:bottom_right}</a:t>
                       </a:r>
                     </a:p>
                   </a:txBody>
-                  <a:tcPr/>
+                  <a:tcPr>
+                    <a:solidFill>
+                      <a:srgbClr val="FFFFFF"/>
+                    </a:solidFill>
+                  </a:tcPr>
                 </a:tc>
                 <a:tc>
                   <a:txBody>
                     <a:bodyPr/>
                     <a:lstStyle/>
                     <a:p>
+                      <a:pPr algn="l"/>
                       <a:r>
-                        <a:t>Headers/Footers</a:t>
+                        <a:rPr lang="en-US" sz="1100" dirty="0">
+                          <a:solidFill>
+                            <a:srgbClr val="333333"/>
+                          </a:solidFill>
+                          <a:latin typeface="Calibri"/>
+                        </a:rPr>
+                        <a:t>Pinning headers, footers, and fixed elements</a:t>
                       </a:r>
                     </a:p>
                   </a:txBody>
-                  <a:tcPr/>
+                  <a:tcPr>
+                    <a:solidFill>
+                      <a:srgbClr val="FFFFFF"/>
+                    </a:solidFill>
+                  </a:tcPr>
                 </a:tc>
               </a:tr>
-              <a:tr h="742950">
+              <a:tr h="685800">
                 <a:tc>
                   <a:txBody>
                     <a:bodyPr/>
                     <a:lstStyle/>
                     <a:p>
+                      <a:pPr algn="l"/>
                       <a:r>
+                        <a:rPr lang="en-US" sz="1100" b="1" dirty="0">
+                          <a:solidFill>
+                            <a:srgbClr val="1F497D"/>
+                          </a:solidFill>
+                          <a:latin typeface="Calibri"/>
+                        </a:rPr>
                         <a:t>Grid</a:t>
                       </a:r>
                     </a:p>
                   </a:txBody>
-                  <a:tcPr/>
+                  <a:tcPr>
+                    <a:solidFill>
+                      <a:srgbClr val="DCE6F1"/>
+                    </a:solidFill>
+                  </a:tcPr>
                 </a:tc>
                 <a:tc>
                   <a:txBody>
                     <a:bodyPr/>
                     <a:lstStyle/>
                     <a:p>
+                      <a:pPr algn="l"/>
                       <a:r>
+                        <a:rPr lang="en-US" sz="1100" dirty="0">
+                          <a:solidFill>
+                            <a:srgbClr val="333333"/>
+                          </a:solidFill>
+                          <a:latin typeface="Courier New"/>
+                        </a:rPr>
                         <a:t>{grid_row:2, grid_col:2}</a:t>
                       </a:r>
                     </a:p>
                   </a:txBody>
-                  <a:tcPr/>
+                  <a:tcPr>
+                    <a:solidFill>
+                      <a:srgbClr val="DCE6F1"/>
+                    </a:solidFill>
+                  </a:tcPr>
                 </a:tc>
                 <a:tc>
                   <a:txBody>
                     <a:bodyPr/>
                     <a:lstStyle/>
                     <a:p>
+                      <a:pPr algn="l"/>
                       <a:r>
-                        <a:t>Structured Grids</a:t>
+                        <a:rPr lang="en-US" sz="1100" dirty="0">
+                          <a:solidFill>
+                            <a:srgbClr val="333333"/>
+                          </a:solidFill>
+                          <a:latin typeface="Calibri"/>
+                        </a:rPr>
+                        <a:t>Structured grid layouts (12x12 cell system)</a:t>
                       </a:r>
                     </a:p>
                   </a:txBody>
-                  <a:tcPr/>
+                  <a:tcPr>
+                    <a:solidFill>
+                      <a:srgbClr val="DCE6F1"/>
+                    </a:solidFill>
+                  </a:tcPr>
                 </a:tc>
               </a:tr>
-              <a:tr h="742950">
+              <a:tr h="685800">
                 <a:tc>
                   <a:txBody>
                     <a:bodyPr/>
                     <a:lstStyle/>
                     <a:p>
+                      <a:pPr algn="l"/>
                       <a:r>
+                        <a:rPr lang="en-US" sz="1100" b="1" dirty="0">
+                          <a:solidFill>
+                            <a:srgbClr val="1F497D"/>
+                          </a:solidFill>
+                          <a:latin typeface="Calibri"/>
+                        </a:rPr>
                         <a:t>Excel-Ref</a:t>
                       </a:r>
                     </a:p>
                   </a:txBody>
-                  <a:tcPr/>
+                  <a:tcPr>
+                    <a:solidFill>
+                      <a:srgbClr val="FFFFFF"/>
+                    </a:solidFill>
+                  </a:tcPr>
                 </a:tc>
                 <a:tc>
                   <a:txBody>
                     <a:bodyPr/>
                     <a:lstStyle/>
                     <a:p>
+                      <a:pPr algn="l"/>
                       <a:r>
+                        <a:rPr lang="en-US" sz="1100" dirty="0">
+                          <a:solidFill>
+                            <a:srgbClr val="333333"/>
+                          </a:solidFill>
+                          <a:latin typeface="Courier New"/>
+                        </a:rPr>
                         <a:t>{grid:C4}</a:t>
                       </a:r>
                     </a:p>
                   </a:txBody>
-                  <a:tcPr/>
+                  <a:tcPr>
+                    <a:solidFill>
+                      <a:srgbClr val="FFFFFF"/>
+                    </a:solidFill>
+                  </a:tcPr>
                 </a:tc>
                 <a:tc>
                   <a:txBody>
                     <a:bodyPr/>
                     <a:lstStyle/>
                     <a:p>
+                      <a:pPr algn="l"/>
                       <a:r>
-                        <a:t>Excel Users</a:t>
+                        <a:rPr lang="en-US" sz="1100" dirty="0">
+                          <a:solidFill>
+                            <a:srgbClr val="333333"/>
+                          </a:solidFill>
+                          <a:latin typeface="Calibri"/>
+                        </a:rPr>
+                        <a:t>Spreadsheet-style cell references for Excel users</a:t>
                       </a:r>
                     </a:p>
                   </a:txBody>
-                  <a:tcPr/>
+                  <a:tcPr>
+                    <a:solidFill>
+                      <a:srgbClr val="FFFFFF"/>
+                    </a:solidFill>
+                  </a:tcPr>
                 </a:tc>
               </a:tr>
-              <a:tr h="742950">
+              <a:tr h="685800">
                 <a:tc>
                   <a:txBody>
                     <a:bodyPr/>
                     <a:lstStyle/>
                     <a:p>
+                      <a:pPr algn="l"/>
                       <a:r>
+                        <a:rPr lang="en-US" sz="1100" b="1" dirty="0">
+                          <a:solidFill>
+                            <a:srgbClr val="1F497D"/>
+                          </a:solidFill>
+                          <a:latin typeface="Calibri"/>
+                        </a:rPr>
                         <a:t>Absolute</a:t>
                       </a:r>
                     </a:p>
                   </a:txBody>
-                  <a:tcPr/>
+                  <a:tcPr>
+                    <a:solidFill>
+                      <a:srgbClr val="DCE6F1"/>
+                    </a:solidFill>
+                  </a:tcPr>
                 </a:tc>
                 <a:tc>
                   <a:txBody>
                     <a:bodyPr/>
                     <a:lstStyle/>
                     <a:p>
+                      <a:pPr algn="l"/>
                       <a:r>
+                        <a:rPr lang="en-US" sz="1100" dirty="0">
+                          <a:solidFill>
+                            <a:srgbClr val="333333"/>
+                          </a:solidFill>
+                          <a:latin typeface="Courier New"/>
+                        </a:rPr>
                         <a:t>{left:1.5, top:2.0}</a:t>
                       </a:r>
                     </a:p>
                   </a:txBody>
-                  <a:tcPr/>
+                  <a:tcPr>
+                    <a:solidFill>
+                      <a:srgbClr val="DCE6F1"/>
+                    </a:solidFill>
+                  </a:tcPr>
                 </a:tc>
                 <a:tc>
                   <a:txBody>
                     <a:bodyPr/>
                     <a:lstStyle/>
                     <a:p>
+                      <a:pPr algn="l"/>
                       <a:r>
-                        <a:t>Exact Specs (Inches)</a:t>
+                        <a:rPr lang="en-US" sz="1100" dirty="0">
+                          <a:solidFill>
+                            <a:srgbClr val="333333"/>
+                          </a:solidFill>
+                          <a:latin typeface="Calibri"/>
+                        </a:rPr>
+                        <a:t>Exact positioning in inches for precise design specs</a:t>
                       </a:r>
                     </a:p>
                   </a:txBody>
-                  <a:tcPr/>
+                  <a:tcPr>
+                    <a:solidFill>
+                      <a:srgbClr val="DCE6F1"/>
+                    </a:solidFill>
+                  </a:tcPr>
                 </a:tc>
               </a:tr>
             </a:tbl>
@@ -4865,23 +5103,95 @@
       <p:grpSpPr/>
       <p:sp>
         <p:nvSpPr>
-          <p:cNvPr id="2" name="Rectangle 1"/>
-          <p:cNvSpPr/>
+          <p:cNvPr id="10" name="Title"/>
+          <p:cNvSpPr txBox="1"/>
           <p:nvPr/>
         </p:nvSpPr>
         <p:spPr>
           <a:xfrm>
-            <a:off x="609584" y="1714500"/>
-            <a:ext cx="3047923" cy="3771900"/>
+            <a:off x="457200" y="274638"/>
+            <a:ext cx="8229600" cy="1143000"/>
           </a:xfrm>
           <a:prstGeom prst="rect">
             <a:avLst/>
           </a:prstGeom>
+          <a:noFill/>
+        </p:spPr>
+        <p:txBody>
+          <a:bodyPr wrap="square">
+            <a:spAutoFit/>
+          </a:bodyPr>
+          <a:lstStyle/>
+          <a:p>
+            <a:r>
+              <a:rPr lang="en-US" sz="2800" b="1" dirty="0">
+                <a:solidFill>
+                  <a:srgbClr val="1F497D"/>
+                </a:solidFill>
+                <a:latin typeface="Calibri"/>
+              </a:rPr>
+              <a:t>Visual Design Capabilities</a:t>
+            </a:r>
+          </a:p>
+        </p:txBody>
+      </p:sp>
+      <p:sp>
+        <p:nvSpPr>
+          <p:cNvPr id="11" name="Subtitle"/>
+          <p:cNvSpPr txBox="1"/>
+          <p:nvPr/>
+        </p:nvSpPr>
+        <p:spPr>
+          <a:xfrm>
+            <a:off x="457200" y="1371600"/>
+            <a:ext cx="8229600" cy="457200"/>
+          </a:xfrm>
+          <a:prstGeom prst="rect">
+            <a:avLst/>
+          </a:prstGeom>
+          <a:noFill/>
+        </p:spPr>
+        <p:txBody>
+          <a:bodyPr wrap="square">
+            <a:spAutoFit/>
+          </a:bodyPr>
+          <a:lstStyle/>
+          <a:p>
+            <a:r>
+              <a:rPr lang="en-US" sz="1400" dirty="0">
+                <a:solidFill>
+                  <a:srgbClr val="595959"/>
+                </a:solidFill>
+                <a:latin typeface="Calibri"/>
+              </a:rPr>
+              <a:t>Shapes, connectors, and visual elements created with ppt_add_shape and related tools</a:t>
+            </a:r>
+          </a:p>
+        </p:txBody>
+      </p:sp>
+      <p:sp>
+        <p:nvSpPr>
+          <p:cNvPr id="2" name="Rectangle 1"/>
+          <p:cNvSpPr/>
+          <p:nvPr/>
+        </p:nvSpPr>
+        <p:spPr>
+          <a:xfrm>
+            <a:off x="457200" y="2057400"/>
+            <a:ext cx="2743200" cy="2286000"/>
+          </a:xfrm>
+          <a:prstGeom prst="roundRect">
+            <a:avLst>
+              <a:gd name="adj" fmla="val 8000"/>
+            </a:avLst>
+          </a:prstGeom>
           <a:solidFill>
             <a:srgbClr val="0070C0"/>
           </a:solidFill>
-          <a:ln>
-            <a:noFill/>
+          <a:ln w="19050">
+            <a:solidFill>
+              <a:srgbClr val="005A9E"/>
+            </a:solidFill>
           </a:ln>
         </p:spPr>
         <p:style>
@@ -4899,10 +5209,35 @@
           </a:fontRef>
         </p:style>
         <p:txBody>
-          <a:bodyPr rtlCol="0" anchor="ctr"/>
+          <a:bodyPr rtlCol="0" anchor="t" lIns="91440" tIns="45720" rIns="91440" bIns="45720"/>
           <a:lstStyle/>
           <a:p>
             <a:pPr algn="ctr"/>
+            <a:r>
+              <a:rPr lang="en-US" sz="1600" b="1" dirty="0">
+                <a:solidFill>
+                  <a:srgbClr val="FFFFFF"/>
+                </a:solidFill>
+                <a:latin typeface="Calibri"/>
+              </a:rPr>
+              <a:t>Rectangles</a:t>
+            </a:r>
+          </a:p>
+          <a:p>
+            <a:pPr algn="ctr">
+              <a:spcAft>
+                <a:spcPts val="200"/>
+              </a:spcAft>
+            </a:pPr>
+            <a:r>
+              <a:rPr lang="en-US" sz="1000" dirty="0">
+                <a:solidFill>
+                  <a:srgbClr val="DCE6F1"/>
+                </a:solidFill>
+                <a:latin typeface="Calibri"/>
+              </a:rPr>
+              <a:t>Rounded rects, cards, containers, content blocks</a:t>
+            </a:r>
           </a:p>
         </p:txBody>
       </p:sp>
@@ -4914,8 +5249,8 @@
         </p:nvSpPr>
         <p:spPr>
           <a:xfrm>
-            <a:off x="4267093" y="1714500"/>
-            <a:ext cx="3047923" cy="3771900"/>
+            <a:off x="3657600" y="2057400"/>
+            <a:ext cx="2743200" cy="2286000"/>
           </a:xfrm>
           <a:prstGeom prst="ellipse">
             <a:avLst/>
@@ -4923,8 +5258,10 @@
           <a:solidFill>
             <a:srgbClr val="70AD47"/>
           </a:solidFill>
-          <a:ln>
-            <a:noFill/>
+          <a:ln w="19050">
+            <a:solidFill>
+              <a:srgbClr val="548235"/>
+            </a:solidFill>
           </a:ln>
         </p:spPr>
         <p:style>
@@ -4942,10 +5279,35 @@
           </a:fontRef>
         </p:style>
         <p:txBody>
-          <a:bodyPr rtlCol="0" anchor="ctr"/>
+          <a:bodyPr rtlCol="0" anchor="t" lIns="91440" tIns="45720" rIns="91440" bIns="45720"/>
           <a:lstStyle/>
           <a:p>
             <a:pPr algn="ctr"/>
+            <a:r>
+              <a:rPr lang="en-US" sz="1600" b="1" dirty="0">
+                <a:solidFill>
+                  <a:srgbClr val="FFFFFF"/>
+                </a:solidFill>
+                <a:latin typeface="Calibri"/>
+              </a:rPr>
+              <a:t>Circles</a:t>
+            </a:r>
+          </a:p>
+          <a:p>
+            <a:pPr algn="ctr">
+              <a:spcAft>
+                <a:spcPts val="200"/>
+              </a:spcAft>
+            </a:pPr>
+            <a:r>
+              <a:rPr lang="en-US" sz="1000" dirty="0">
+                <a:solidFill>
+                  <a:srgbClr val="E2EFDA"/>
+                </a:solidFill>
+                <a:latin typeface="Calibri"/>
+              </a:rPr>
+              <a:t>Icons, badges, highlight callouts, process nodes</a:t>
+            </a:r>
           </a:p>
         </p:txBody>
       </p:sp>
@@ -4957,17 +5319,22 @@
         </p:nvSpPr>
         <p:spPr>
           <a:xfrm>
-            <a:off x="7924601" y="3086100"/>
-            <a:ext cx="3657508" cy="1028700"/>
+            <a:off x="6858000" y="2057400"/>
+            <a:ext cx="4876800" cy="2286000"/>
           </a:xfrm>
           <a:prstGeom prst="rightArrow">
-            <a:avLst/>
+            <a:avLst>
+              <a:gd name="adj1" fmla="val 50000"/>
+              <a:gd name="adj2" fmla="val 50000"/>
+            </a:avLst>
           </a:prstGeom>
           <a:solidFill>
             <a:srgbClr val="ED7D31"/>
           </a:solidFill>
-          <a:ln>
-            <a:noFill/>
+          <a:ln w="19050">
+            <a:solidFill>
+              <a:srgbClr val="C55A11"/>
+            </a:solidFill>
           </a:ln>
         </p:spPr>
         <p:style>
@@ -4985,10 +5352,131 @@
           </a:fontRef>
         </p:style>
         <p:txBody>
-          <a:bodyPr rtlCol="0" anchor="ctr"/>
+          <a:bodyPr rtlCol="0" anchor="t" lIns="91440" tIns="45720" rIns="91440" bIns="45720"/>
           <a:lstStyle/>
           <a:p>
             <a:pPr algn="ctr"/>
+            <a:r>
+              <a:rPr lang="en-US" sz="1600" b="1" dirty="0">
+                <a:solidFill>
+                  <a:srgbClr val="FFFFFF"/>
+                </a:solidFill>
+                <a:latin typeface="Calibri"/>
+              </a:rPr>
+              <a:t>Arrows &amp; Connectors</a:t>
+            </a:r>
+          </a:p>
+          <a:p>
+            <a:pPr algn="ctr">
+              <a:spcAft>
+                <a:spcPts val="200"/>
+              </a:spcAft>
+            </a:pPr>
+            <a:r>
+              <a:rPr lang="en-US" sz="1000" dirty="0">
+                <a:solidFill>
+                  <a:srgbClr val="FCE4D6"/>
+                </a:solidFill>
+                <a:latin typeface="Calibri"/>
+              </a:rPr>
+              <a:t>Flowcharts, process flows, directional indicators</a:t>
+            </a:r>
+          </a:p>
+        </p:txBody>
+      </p:sp>
+      <p:sp>
+        <p:nvSpPr>
+          <p:cNvPr id="12" name="FeatureBox"/>
+          <p:cNvSpPr txBox="1"/>
+          <p:nvPr/>
+        </p:nvSpPr>
+        <p:spPr>
+          <a:xfrm>
+            <a:off x="457200" y="4572000"/>
+            <a:ext cx="11277600" cy="1600200"/>
+          </a:xfrm>
+          <a:prstGeom prst="rect">
+            <a:avLst/>
+          </a:prstGeom>
+          <a:noFill/>
+        </p:spPr>
+        <p:txBody>
+          <a:bodyPr wrap="square"/>
+          <a:lstStyle/>
+          <a:p>
+            <a:pPr algn="l">
+              <a:spcAft>
+                <a:spcPts val="400"/>
+              </a:spcAft>
+            </a:pPr>
+            <a:r>
+              <a:rPr lang="en-US" sz="1200" b="1" dirty="0">
+                <a:solidFill>
+                  <a:srgbClr val="1F497D"/>
+                </a:solidFill>
+                <a:latin typeface="Calibri"/>
+              </a:rPr>
+              <a:t>8 dedicated Visual Design tools</a:t>
+            </a:r>
+            <a:r>
+              <a:rPr lang="en-US" sz="1200" dirty="0">
+                <a:solidFill>
+                  <a:srgbClr val="333333"/>
+                </a:solidFill>
+                <a:latin typeface="Calibri"/>
+              </a:rPr>
+              <a:t>  — add, format, reposition, remove shapes, set z-order, backgrounds, and connectors</a:t>
+            </a:r>
+          </a:p>
+          <a:p>
+            <a:pPr algn="l">
+              <a:spcAft>
+                <a:spcPts val="400"/>
+              </a:spcAft>
+            </a:pPr>
+            <a:r>
+              <a:rPr lang="en-US" sz="1200" b="1" dirty="0">
+                <a:solidFill>
+                  <a:srgbClr val="1F497D"/>
+                </a:solidFill>
+                <a:latin typeface="Calibri"/>
+              </a:rPr>
+              <a:t>Full opacity control</a:t>
+            </a:r>
+            <a:r>
+              <a:rPr lang="en-US" sz="1200" dirty="0">
+                <a:solidFill>
+                  <a:srgbClr val="333333"/>
+                </a:solidFill>
+                <a:latin typeface="Calibri"/>
+              </a:rPr>
+              <a:t>  — semi-transparent overlays, layered composites, and watermark effects</a:t>
+            </a:r>
+          </a:p>
+          <a:p>
+            <a:pPr algn="l">
+              <a:spcAft>
+                <a:spcPts val="400"/>
+              </a:spcAft>
+            </a:pPr>
+            <a:r>
+              <a:rPr lang="en-US" sz="1200" b="1" dirty="0">
+                <a:solidFill>
+                  <a:srgbClr val="1F497D"/>
+                </a:solidFill>
+                <a:latin typeface="Calibri"/>
+              </a:rPr>
+              <a:t>Z-order management</a:t>
+            </a:r>
+            <a:r>
+              <a:rPr lang="en-US" sz="1200" dirty="0">
+                <a:solidFill>
+                  <a:srgbClr val="333333"/>
+                </a:solidFill>
+                <a:latin typeface="Calibri"/>
+              </a:rPr>
+              <a:t>  — bring to front / send to back for complex layered compositions</a:t>
+            </a:r>
           </a:p>
         </p:txBody>
       </p:sp>

</xml_diff>